<commit_message>
docs: add Tesco Early Careers to Lecture 5 tech news
</commit_message>
<xml_diff>
--- a/finalised_lectures/lecture-5.pptx
+++ b/finalised_lectures/lecture-5.pptx
@@ -16621,7 +16621,7 @@
         <p:spPr>
           <a:xfrm>
             <a:off x="540000" y="1440000"/>
-            <a:ext cx="5175000" cy="4500000"/>
+            <a:ext cx="5175000" cy="6500000"/>
           </a:xfrm>
           <a:prstGeom prst="rect">
             <a:avLst/>
@@ -16846,6 +16846,137 @@
                 </a:solidFill>
               </a:rPr>
               <a:t>githubuniverse.com</a:t>
+            </a:r>
+          </a:p>
+          <a:p>
+            <a:pPr indent="-336550" lvl="0" marL="457200" rtl="0" algn="l">
+              <a:lnSpc>
+                <a:spcPct val="150000"/>
+              </a:lnSpc>
+              <a:spcBef>
+                <a:spcPts val="1000"/>
+              </a:spcBef>
+              <a:spcAft>
+                <a:spcPts val="0"/>
+              </a:spcAft>
+              <a:buClr>
+                <a:schemeClr val="dk1"/>
+              </a:buClr>
+              <a:buSzPts val="1700"/>
+              <a:buChar char="●"/>
+            </a:pPr>
+            <a:r>
+              <a:rPr lang="en-GB" sz="1700" u="sng">
+                <a:hlinkClick r:id="rId6"/>
+                <a:solidFill>
+                  <a:schemeClr val="hlink"/>
+                </a:solidFill>
+              </a:rPr>
+              <a:t>Tesco Technology Early Careers</a:t>
+            </a:r>
+            <a:r>
+              <a:rPr lang="en-GB" sz="1700">
+                <a:solidFill>
+                  <a:schemeClr val="dk1"/>
+                </a:solidFill>
+              </a:rPr>
+              <a:t>:</a:t>
+            </a:r>
+          </a:p>
+          <a:p>
+            <a:pPr indent="-336550" lvl="1" marL="914400" rtl="0" algn="l">
+              <a:lnSpc>
+                <a:spcPct val="150000"/>
+              </a:lnSpc>
+              <a:spcBef>
+                <a:spcPts val="1000"/>
+              </a:spcBef>
+              <a:spcAft>
+                <a:spcPts val="0"/>
+              </a:spcAft>
+              <a:buClr>
+                <a:schemeClr val="dk1"/>
+              </a:buClr>
+              <a:buSzPts val="1700"/>
+              <a:buChar char="○"/>
+            </a:pPr>
+            <a:r>
+              <a:rPr lang="en-GB" sz="1700">
+                <a:solidFill>
+                  <a:schemeClr val="dk1"/>
+                </a:solidFill>
+              </a:rPr>
+              <a:t>Internships (Year 2) and graduate schemes across software, data, and security.</a:t>
+            </a:r>
+          </a:p>
+          <a:p>
+            <a:pPr indent="-336550" lvl="1" marL="914400" rtl="0" algn="l">
+              <a:lnSpc>
+                <a:spcPct val="150000"/>
+              </a:lnSpc>
+              <a:spcBef>
+                <a:spcPts val="1000"/>
+              </a:spcBef>
+              <a:spcAft>
+                <a:spcPts val="0"/>
+              </a:spcAft>
+              <a:buClr>
+                <a:schemeClr val="dk1"/>
+              </a:buClr>
+              <a:buSzPts val="1700"/>
+              <a:buChar char="○"/>
+            </a:pPr>
+            <a:r>
+              <a:rPr lang="en-GB" sz="1700">
+                <a:solidFill>
+                  <a:schemeClr val="dk1"/>
+                </a:solidFill>
+              </a:rPr>
+              <a:t>Guidance from alumnus Ruben Tanner (TPM at Tesco): </a:t>
+            </a:r>
+            <a:r>
+              <a:rPr lang="en-GB" sz="1700" u="sng">
+                <a:hlinkClick r:id="rId7"/>
+                <a:solidFill>
+                  <a:schemeClr val="hlink"/>
+                </a:solidFill>
+              </a:rPr>
+              <a:t>Ruben.tanner1@tesco.com</a:t>
+            </a:r>
+          </a:p>
+          <a:p>
+            <a:pPr indent="-336550" lvl="1" marL="914400" rtl="0" algn="l">
+              <a:lnSpc>
+                <a:spcPct val="150000"/>
+              </a:lnSpc>
+              <a:spcBef>
+                <a:spcPts val="1000"/>
+              </a:spcBef>
+              <a:spcAft>
+                <a:spcPts val="0"/>
+              </a:spcAft>
+              <a:buClr>
+                <a:schemeClr val="dk1"/>
+              </a:buClr>
+              <a:buSzPts val="1700"/>
+              <a:buChar char="○"/>
+            </a:pPr>
+            <a:r>
+              <a:rPr lang="en-GB" sz="1700">
+                <a:solidFill>
+                  <a:schemeClr val="dk1"/>
+                </a:solidFill>
+              </a:rPr>
+              <a:t>Apply: </a:t>
+            </a:r>
+            <a:r>
+              <a:rPr lang="en-GB" sz="1700" u="sng">
+                <a:hlinkClick r:id="rId6"/>
+                <a:solidFill>
+                  <a:schemeClr val="hlink"/>
+                </a:solidFill>
+              </a:rPr>
+              <a:t>tesco.com/careers/en-GB/our-teams/early-careers</a:t>
             </a:r>
           </a:p>
         </p:txBody>

</xml_diff>

<commit_message>
docs: streamline Tesco early careers tech news
</commit_message>
<xml_diff>
--- a/finalised_lectures/lecture-5.pptx
+++ b/finalised_lectures/lecture-5.pptx
@@ -16907,41 +16907,6 @@
                 </a:solidFill>
               </a:rPr>
               <a:t>Internships (Year 2) and graduate schemes across software, data, and security.</a:t>
-            </a:r>
-          </a:p>
-          <a:p>
-            <a:pPr indent="-336550" lvl="1" marL="914400" rtl="0" algn="l">
-              <a:lnSpc>
-                <a:spcPct val="150000"/>
-              </a:lnSpc>
-              <a:spcBef>
-                <a:spcPts val="1000"/>
-              </a:spcBef>
-              <a:spcAft>
-                <a:spcPts val="0"/>
-              </a:spcAft>
-              <a:buClr>
-                <a:schemeClr val="dk1"/>
-              </a:buClr>
-              <a:buSzPts val="1700"/>
-              <a:buChar char="○"/>
-            </a:pPr>
-            <a:r>
-              <a:rPr lang="en-GB" sz="1700">
-                <a:solidFill>
-                  <a:schemeClr val="dk1"/>
-                </a:solidFill>
-              </a:rPr>
-              <a:t>Guidance from alumnus Ruben Tanner (TPM at Tesco): </a:t>
-            </a:r>
-            <a:r>
-              <a:rPr lang="en-GB" sz="1700" u="sng">
-                <a:hlinkClick r:id="rId7"/>
-                <a:solidFill>
-                  <a:schemeClr val="hlink"/>
-                </a:solidFill>
-              </a:rPr>
-              <a:t>Ruben.tanner1@tesco.com</a:t>
             </a:r>
           </a:p>
           <a:p>

</xml_diff>

<commit_message>
docs: align Lecture 5 news slide with downloaded version
</commit_message>
<xml_diff>
--- a/finalised_lectures/lecture-5.pptx
+++ b/finalised_lectures/lecture-5.pptx
@@ -16621,7 +16621,7 @@
         <p:spPr>
           <a:xfrm>
             <a:off x="540000" y="1440000"/>
-            <a:ext cx="5175000" cy="6500000"/>
+            <a:ext cx="5175000" cy="6967500"/>
           </a:xfrm>
           <a:prstGeom prst="rect">
             <a:avLst/>
@@ -16766,20 +16766,12 @@
             </a:pPr>
             <a:r>
               <a:rPr lang="en-GB" sz="1700" u="sng">
+                <a:solidFill>
+                  <a:schemeClr val="hlink"/>
+                </a:solidFill>
                 <a:hlinkClick r:id="rId5"/>
-                <a:solidFill>
-                  <a:schemeClr val="hlink"/>
-                </a:solidFill>
               </a:rPr>
               <a:t>GitHub Universe 2026</a:t>
-            </a:r>
-            <a:r>
-              <a:rPr lang="en-GB" sz="1700">
-                <a:solidFill>
-                  <a:schemeClr val="dk1"/>
-                </a:solidFill>
-              </a:rPr>
-              <a:t>:</a:t>
             </a:r>
             <a:endParaRPr sz="1700">
               <a:solidFill>
@@ -16810,8 +16802,13 @@
                   <a:schemeClr val="dk1"/>
                 </a:solidFill>
               </a:rPr>
-              <a:t>Free virtual registration for students (28–29 October); live keynotes, AI workflows, and workshops.</a:t>
-            </a:r>
+              <a:t>Free virtual event (28–29 October); live keynotes, AI workflows, and workshops.</a:t>
+            </a:r>
+            <a:endParaRPr sz="1700">
+              <a:solidFill>
+                <a:schemeClr val="dk1"/>
+              </a:solidFill>
+            </a:endParaRPr>
           </a:p>
           <a:p>
             <a:pPr indent="-336550" lvl="1" marL="914400" rtl="0" algn="l">
@@ -16836,17 +16833,22 @@
                   <a:schemeClr val="dk1"/>
                 </a:solidFill>
               </a:rPr>
-              <a:t>Sign up: </a:t>
+              <a:t>Sign up at </a:t>
             </a:r>
             <a:r>
               <a:rPr lang="en-GB" sz="1700" u="sng">
-                <a:hlinkClick r:id="rId5"/>
                 <a:solidFill>
                   <a:schemeClr val="hlink"/>
                 </a:solidFill>
+                <a:hlinkClick r:id="rId6"/>
               </a:rPr>
               <a:t>githubuniverse.com</a:t>
             </a:r>
+            <a:endParaRPr sz="1700">
+              <a:solidFill>
+                <a:schemeClr val="dk1"/>
+              </a:solidFill>
+            </a:endParaRPr>
           </a:p>
           <a:p>
             <a:pPr indent="-336550" lvl="0" marL="457200" rtl="0" algn="l">
@@ -16867,10 +16869,10 @@
             </a:pPr>
             <a:r>
               <a:rPr lang="en-GB" sz="1700" u="sng">
-                <a:hlinkClick r:id="rId6"/>
                 <a:solidFill>
                   <a:schemeClr val="hlink"/>
                 </a:solidFill>
+                <a:hlinkClick r:id="rId7"/>
               </a:rPr>
               <a:t>Tesco Technology Early Careers</a:t>
             </a:r>
@@ -16882,6 +16884,11 @@
               </a:rPr>
               <a:t>:</a:t>
             </a:r>
+            <a:endParaRPr sz="1700">
+              <a:solidFill>
+                <a:schemeClr val="dk1"/>
+              </a:solidFill>
+            </a:endParaRPr>
           </a:p>
           <a:p>
             <a:pPr indent="-336550" lvl="1" marL="914400" rtl="0" algn="l">
@@ -16906,8 +16913,13 @@
                   <a:schemeClr val="dk1"/>
                 </a:solidFill>
               </a:rPr>
-              <a:t>Internships (Year 2) and graduate schemes across software, data, and security.</a:t>
-            </a:r>
+              <a:t>Internships and graduate schemes across software, data, and security.</a:t>
+            </a:r>
+            <a:endParaRPr sz="1700">
+              <a:solidFill>
+                <a:schemeClr val="dk1"/>
+              </a:solidFill>
+            </a:endParaRPr>
           </a:p>
           <a:p>
             <a:pPr indent="-336550" lvl="1" marL="914400" rtl="0" algn="l">
@@ -16918,7 +16930,7 @@
                 <a:spcPts val="1000"/>
               </a:spcBef>
               <a:spcAft>
-                <a:spcPts val="0"/>
+                <a:spcPts val="1000"/>
               </a:spcAft>
               <a:buClr>
                 <a:schemeClr val="dk1"/>
@@ -16932,17 +16944,22 @@
                   <a:schemeClr val="dk1"/>
                 </a:solidFill>
               </a:rPr>
-              <a:t>Apply: </a:t>
+              <a:t>Apply at: </a:t>
             </a:r>
             <a:r>
               <a:rPr lang="en-GB" sz="1700" u="sng">
-                <a:hlinkClick r:id="rId6"/>
                 <a:solidFill>
                   <a:schemeClr val="hlink"/>
                 </a:solidFill>
+                <a:hlinkClick r:id="rId8"/>
               </a:rPr>
               <a:t>tesco.com/careers/en-GB/our-teams/early-careers</a:t>
             </a:r>
+            <a:endParaRPr sz="1700">
+              <a:solidFill>
+                <a:schemeClr val="dk1"/>
+              </a:solidFill>
+            </a:endParaRPr>
           </a:p>
         </p:txBody>
       </p:sp>
@@ -20136,13 +20153,13 @@
         <a:srgbClr val="212121"/>
       </a:accent2>
       <a:accent3>
-        <a:srgbClr val="FF5733"/>
+        <a:srgbClr val="78909C"/>
       </a:accent3>
       <a:accent4>
-        <a:srgbClr val="34D1BF"/>
+        <a:srgbClr val="FFAB40"/>
       </a:accent4>
       <a:accent5>
-        <a:srgbClr val="F9E79F"/>
+        <a:srgbClr val="0097A7"/>
       </a:accent5>
       <a:accent6>
         <a:srgbClr val="EEFF41"/>
@@ -20415,13 +20432,13 @@
         <a:srgbClr val="212121"/>
       </a:accent2>
       <a:accent3>
-        <a:srgbClr val="78909C"/>
+        <a:srgbClr val="FF5733"/>
       </a:accent3>
       <a:accent4>
-        <a:srgbClr val="FFAB40"/>
+        <a:srgbClr val="34D1BF"/>
       </a:accent4>
       <a:accent5>
-        <a:srgbClr val="0097A7"/>
+        <a:srgbClr val="F9E79F"/>
       </a:accent5>
       <a:accent6>
         <a:srgbClr val="EEFF41"/>

</xml_diff>